<commit_message>
refactor: Host Intelligence panel fully renovated (pending indications section)
</commit_message>
<xml_diff>
--- a/Icons/IconMaker.pptx
+++ b/Icons/IconMaker.pptx
@@ -104,13 +104,18 @@
       </a:defRPr>
     </a:lvl9pPr>
   </p:defaultTextStyle>
+  <p:extLst>
+    <p:ext uri="{EFAFB233-063F-42B5-8137-9DF3F51BA10A}">
+      <p15:sldGuideLst xmlns:p15="http://schemas.microsoft.com/office/powerpoint/2012/main"/>
+    </p:ext>
+  </p:extLst>
 </p:presentation>
 </file>
 
 <file path=ppt/revisionInfo.xml><?xml version="1.0" encoding="utf-8"?>
 <p1510:revInfo xmlns:a="http://schemas.openxmlformats.org/drawingml/2006/main" xmlns:r="http://schemas.openxmlformats.org/officeDocument/2006/relationships" xmlns:p1510="http://schemas.microsoft.com/office/powerpoint/2015/10/main">
   <p1510:revLst>
-    <p1510:client id="{02054883-E5A4-4578-910B-0EDC9BEF8332}" v="5" dt="2026-04-03T19:54:30.053"/>
+    <p1510:client id="{4A27B9ED-8C43-40A2-95C9-684B04E3DDB2}" v="15" dt="2026-04-05T21:43:39.645"/>
   </p1510:revLst>
 </p1510:revInfo>
 </file>
@@ -119,79 +124,111 @@
 <pc:chgInfo xmlns:a="http://schemas.openxmlformats.org/drawingml/2006/main" xmlns:r="http://schemas.openxmlformats.org/officeDocument/2006/relationships" xmlns:ac="http://schemas.microsoft.com/office/drawing/2013/main/command" xmlns:pc="http://schemas.microsoft.com/office/powerpoint/2013/main/command">
   <pc:docChgLst>
     <pc:chgData name="Santiago Ortiz" userId="8b76e105705800ef" providerId="LiveId" clId="{763C6895-C760-4459-BCBE-6004E971A178}"/>
-    <pc:docChg chg="undo custSel addSld modSld">
-      <pc:chgData name="Santiago Ortiz" userId="8b76e105705800ef" providerId="LiveId" clId="{763C6895-C760-4459-BCBE-6004E971A178}" dt="2026-04-03T19:54:34.590" v="48" actId="207"/>
+    <pc:docChg chg="undo redo custSel addSld modSld">
+      <pc:chgData name="Santiago Ortiz" userId="8b76e105705800ef" providerId="LiveId" clId="{763C6895-C760-4459-BCBE-6004E971A178}" dt="2026-04-05T21:43:39.645" v="169" actId="164"/>
       <pc:docMkLst>
         <pc:docMk/>
       </pc:docMkLst>
       <pc:sldChg chg="addSp delSp modSp new mod">
-        <pc:chgData name="Santiago Ortiz" userId="8b76e105705800ef" providerId="LiveId" clId="{763C6895-C760-4459-BCBE-6004E971A178}" dt="2026-04-03T19:54:34.590" v="48" actId="207"/>
+        <pc:chgData name="Santiago Ortiz" userId="8b76e105705800ef" providerId="LiveId" clId="{763C6895-C760-4459-BCBE-6004E971A178}" dt="2026-04-05T21:43:39.645" v="169" actId="164"/>
         <pc:sldMkLst>
           <pc:docMk/>
           <pc:sldMk cId="430812222" sldId="256"/>
         </pc:sldMkLst>
-        <pc:spChg chg="del">
-          <ac:chgData name="Santiago Ortiz" userId="8b76e105705800ef" providerId="LiveId" clId="{763C6895-C760-4459-BCBE-6004E971A178}" dt="2026-04-03T19:15:14.513" v="1" actId="478"/>
+        <pc:spChg chg="add mod">
+          <ac:chgData name="Santiago Ortiz" userId="8b76e105705800ef" providerId="LiveId" clId="{763C6895-C760-4459-BCBE-6004E971A178}" dt="2026-04-05T21:27:25.326" v="89" actId="164"/>
           <ac:spMkLst>
             <pc:docMk/>
             <pc:sldMk cId="430812222" sldId="256"/>
-            <ac:spMk id="2" creationId="{C07092A3-34A0-E125-8FDA-33EE938D6C3F}"/>
+            <ac:spMk id="7" creationId="{C30E46E7-D177-809F-E915-080AFFA8727C}"/>
           </ac:spMkLst>
         </pc:spChg>
-        <pc:spChg chg="del">
-          <ac:chgData name="Santiago Ortiz" userId="8b76e105705800ef" providerId="LiveId" clId="{763C6895-C760-4459-BCBE-6004E971A178}" dt="2026-04-03T19:15:14.513" v="1" actId="478"/>
+        <pc:spChg chg="add mod">
+          <ac:chgData name="Santiago Ortiz" userId="8b76e105705800ef" providerId="LiveId" clId="{763C6895-C760-4459-BCBE-6004E971A178}" dt="2026-04-05T21:43:38.198" v="167" actId="33987"/>
           <ac:spMkLst>
             <pc:docMk/>
             <pc:sldMk cId="430812222" sldId="256"/>
-            <ac:spMk id="3" creationId="{5F0BD2E9-5BB8-CF97-DA01-8B8B3B1B3544}"/>
+            <ac:spMk id="19" creationId="{D8B3EA34-C0D0-D137-BFAB-3D6EE27056BC}"/>
           </ac:spMkLst>
         </pc:spChg>
-        <pc:spChg chg="add mod ord">
-          <ac:chgData name="Santiago Ortiz" userId="8b76e105705800ef" providerId="LiveId" clId="{763C6895-C760-4459-BCBE-6004E971A178}" dt="2026-04-03T19:47:14.353" v="33" actId="207"/>
-          <ac:spMkLst>
-            <pc:docMk/>
-            <pc:sldMk cId="430812222" sldId="256"/>
-            <ac:spMk id="6" creationId="{3455EB38-99D3-B59F-78FD-FE219565DB97}"/>
-          </ac:spMkLst>
-        </pc:spChg>
-        <pc:grpChg chg="add del mod">
-          <ac:chgData name="Santiago Ortiz" userId="8b76e105705800ef" providerId="LiveId" clId="{763C6895-C760-4459-BCBE-6004E971A178}" dt="2026-04-03T19:48:43.320" v="34" actId="478"/>
+        <pc:grpChg chg="add mod">
+          <ac:chgData name="Santiago Ortiz" userId="8b76e105705800ef" providerId="LiveId" clId="{763C6895-C760-4459-BCBE-6004E971A178}" dt="2026-04-05T21:27:25.326" v="89" actId="164"/>
           <ac:grpSpMkLst>
             <pc:docMk/>
             <pc:sldMk cId="430812222" sldId="256"/>
-            <ac:grpSpMk id="7" creationId="{14B22CD5-AC94-8099-D9AA-2DC6CF493238}"/>
+            <ac:grpSpMk id="6" creationId="{433474F7-2297-8B8E-9532-FD0C14FB9A43}"/>
           </ac:grpSpMkLst>
         </pc:grpChg>
-        <pc:picChg chg="add mod">
-          <ac:chgData name="Santiago Ortiz" userId="8b76e105705800ef" providerId="LiveId" clId="{763C6895-C760-4459-BCBE-6004E971A178}" dt="2026-04-03T19:44:26.344" v="29" actId="208"/>
+        <pc:grpChg chg="add del mod">
+          <ac:chgData name="Santiago Ortiz" userId="8b76e105705800ef" providerId="LiveId" clId="{763C6895-C760-4459-BCBE-6004E971A178}" dt="2026-04-05T21:29:03.325" v="90" actId="478"/>
+          <ac:grpSpMkLst>
+            <pc:docMk/>
+            <pc:sldMk cId="430812222" sldId="256"/>
+            <ac:grpSpMk id="8" creationId="{CE996A5D-7A9A-D8B1-9256-669292CE14B3}"/>
+          </ac:grpSpMkLst>
+        </pc:grpChg>
+        <pc:grpChg chg="add mod">
+          <ac:chgData name="Santiago Ortiz" userId="8b76e105705800ef" providerId="LiveId" clId="{763C6895-C760-4459-BCBE-6004E971A178}" dt="2026-04-05T21:43:39.645" v="169" actId="164"/>
+          <ac:grpSpMkLst>
+            <pc:docMk/>
+            <pc:sldMk cId="430812222" sldId="256"/>
+            <ac:grpSpMk id="18" creationId="{A11CBD9B-FDAA-4D8B-8E14-37B7442EC603}"/>
+          </ac:grpSpMkLst>
+        </pc:grpChg>
+        <pc:picChg chg="add mod ord">
+          <ac:chgData name="Santiago Ortiz" userId="8b76e105705800ef" providerId="LiveId" clId="{763C6895-C760-4459-BCBE-6004E971A178}" dt="2026-04-05T21:21:59.459" v="67" actId="164"/>
           <ac:picMkLst>
             <pc:docMk/>
             <pc:sldMk cId="430812222" sldId="256"/>
-            <ac:picMk id="5" creationId="{B2196D42-E319-F189-BF3E-C09E371632CF}"/>
+            <ac:picMk id="3" creationId="{385ECAF5-634D-4A29-F8AE-C95E46F8FFA9}"/>
+          </ac:picMkLst>
+        </pc:picChg>
+        <pc:picChg chg="add mod">
+          <ac:chgData name="Santiago Ortiz" userId="8b76e105705800ef" providerId="LiveId" clId="{763C6895-C760-4459-BCBE-6004E971A178}" dt="2026-04-05T21:21:59.459" v="67" actId="164"/>
+          <ac:picMkLst>
+            <pc:docMk/>
+            <pc:sldMk cId="430812222" sldId="256"/>
+            <ac:picMk id="5" creationId="{2FD501A9-3217-0594-B1CC-6FCCF2582D66}"/>
+          </ac:picMkLst>
+        </pc:picChg>
+        <pc:picChg chg="add del mod ord">
+          <ac:chgData name="Santiago Ortiz" userId="8b76e105705800ef" providerId="LiveId" clId="{763C6895-C760-4459-BCBE-6004E971A178}" dt="2026-04-05T21:43:23.139" v="150" actId="478"/>
+          <ac:picMkLst>
+            <pc:docMk/>
+            <pc:sldMk cId="430812222" sldId="256"/>
+            <ac:picMk id="10" creationId="{1A74713C-DCD4-1CAA-78D5-B1A6259DE90D}"/>
           </ac:picMkLst>
         </pc:picChg>
         <pc:picChg chg="add del mod">
-          <ac:chgData name="Santiago Ortiz" userId="8b76e105705800ef" providerId="LiveId" clId="{763C6895-C760-4459-BCBE-6004E971A178}" dt="2026-04-03T19:50:18.019" v="39" actId="478"/>
+          <ac:chgData name="Santiago Ortiz" userId="8b76e105705800ef" providerId="LiveId" clId="{763C6895-C760-4459-BCBE-6004E971A178}" dt="2026-04-05T21:43:23.006" v="146" actId="478"/>
           <ac:picMkLst>
             <pc:docMk/>
             <pc:sldMk cId="430812222" sldId="256"/>
-            <ac:picMk id="9" creationId="{DAD80B22-936C-0FCE-6653-497644339185}"/>
+            <ac:picMk id="12" creationId="{28961133-3A74-161D-1042-F33B53B36C1D}"/>
           </ac:picMkLst>
         </pc:picChg>
         <pc:picChg chg="add del mod">
-          <ac:chgData name="Santiago Ortiz" userId="8b76e105705800ef" providerId="LiveId" clId="{763C6895-C760-4459-BCBE-6004E971A178}" dt="2026-04-03T19:51:19.656" v="44" actId="478"/>
-          <ac:picMkLst>
-            <pc:docMk/>
-            <pc:sldMk cId="430812222" sldId="256"/>
-            <ac:picMk id="11" creationId="{54915218-16FB-17F4-FB50-204FE6EDB5D6}"/>
-          </ac:picMkLst>
-        </pc:picChg>
-        <pc:picChg chg="add mod">
-          <ac:chgData name="Santiago Ortiz" userId="8b76e105705800ef" providerId="LiveId" clId="{763C6895-C760-4459-BCBE-6004E971A178}" dt="2026-04-03T19:54:34.590" v="48" actId="207"/>
+          <ac:chgData name="Santiago Ortiz" userId="8b76e105705800ef" providerId="LiveId" clId="{763C6895-C760-4459-BCBE-6004E971A178}" dt="2026-04-05T21:19:55.974" v="49" actId="478"/>
           <ac:picMkLst>
             <pc:docMk/>
             <pc:sldMk cId="430812222" sldId="256"/>
             <ac:picMk id="13" creationId="{A7B3127E-8A0A-1BAD-4F9E-814753B85BDB}"/>
+          </ac:picMkLst>
+        </pc:picChg>
+        <pc:picChg chg="add mod">
+          <ac:chgData name="Santiago Ortiz" userId="8b76e105705800ef" providerId="LiveId" clId="{763C6895-C760-4459-BCBE-6004E971A178}" dt="2026-04-05T21:43:39.645" v="169" actId="164"/>
+          <ac:picMkLst>
+            <pc:docMk/>
+            <pc:sldMk cId="430812222" sldId="256"/>
+            <ac:picMk id="15" creationId="{248B42A6-11F3-AA02-6BE1-0C2312602000}"/>
+          </ac:picMkLst>
+        </pc:picChg>
+        <pc:picChg chg="add mod">
+          <ac:chgData name="Santiago Ortiz" userId="8b76e105705800ef" providerId="LiveId" clId="{763C6895-C760-4459-BCBE-6004E971A178}" dt="2026-04-05T21:43:39.645" v="169" actId="164"/>
+          <ac:picMkLst>
+            <pc:docMk/>
+            <pc:sldMk cId="430812222" sldId="256"/>
+            <ac:picMk id="17" creationId="{5AE1C2AC-7F72-2E18-50EC-484B739A01B4}"/>
           </ac:picMkLst>
         </pc:picChg>
       </pc:sldChg>
@@ -349,7 +386,7 @@
           <a:p>
             <a:fld id="{13CDDF33-5728-4730-A3D1-528809E425CB}" type="datetimeFigureOut">
               <a:rPr lang="es-CO" smtClean="0"/>
-              <a:t>3/04/2026</a:t>
+              <a:t>5/04/2026</a:t>
             </a:fld>
             <a:endParaRPr lang="es-CO"/>
           </a:p>
@@ -549,7 +586,7 @@
           <a:p>
             <a:fld id="{13CDDF33-5728-4730-A3D1-528809E425CB}" type="datetimeFigureOut">
               <a:rPr lang="es-CO" smtClean="0"/>
-              <a:t>3/04/2026</a:t>
+              <a:t>5/04/2026</a:t>
             </a:fld>
             <a:endParaRPr lang="es-CO"/>
           </a:p>
@@ -759,7 +796,7 @@
           <a:p>
             <a:fld id="{13CDDF33-5728-4730-A3D1-528809E425CB}" type="datetimeFigureOut">
               <a:rPr lang="es-CO" smtClean="0"/>
-              <a:t>3/04/2026</a:t>
+              <a:t>5/04/2026</a:t>
             </a:fld>
             <a:endParaRPr lang="es-CO"/>
           </a:p>
@@ -959,7 +996,7 @@
           <a:p>
             <a:fld id="{13CDDF33-5728-4730-A3D1-528809E425CB}" type="datetimeFigureOut">
               <a:rPr lang="es-CO" smtClean="0"/>
-              <a:t>3/04/2026</a:t>
+              <a:t>5/04/2026</a:t>
             </a:fld>
             <a:endParaRPr lang="es-CO"/>
           </a:p>
@@ -1235,7 +1272,7 @@
           <a:p>
             <a:fld id="{13CDDF33-5728-4730-A3D1-528809E425CB}" type="datetimeFigureOut">
               <a:rPr lang="es-CO" smtClean="0"/>
-              <a:t>3/04/2026</a:t>
+              <a:t>5/04/2026</a:t>
             </a:fld>
             <a:endParaRPr lang="es-CO"/>
           </a:p>
@@ -1503,7 +1540,7 @@
           <a:p>
             <a:fld id="{13CDDF33-5728-4730-A3D1-528809E425CB}" type="datetimeFigureOut">
               <a:rPr lang="es-CO" smtClean="0"/>
-              <a:t>3/04/2026</a:t>
+              <a:t>5/04/2026</a:t>
             </a:fld>
             <a:endParaRPr lang="es-CO"/>
           </a:p>
@@ -1918,7 +1955,7 @@
           <a:p>
             <a:fld id="{13CDDF33-5728-4730-A3D1-528809E425CB}" type="datetimeFigureOut">
               <a:rPr lang="es-CO" smtClean="0"/>
-              <a:t>3/04/2026</a:t>
+              <a:t>5/04/2026</a:t>
             </a:fld>
             <a:endParaRPr lang="es-CO"/>
           </a:p>
@@ -2060,7 +2097,7 @@
           <a:p>
             <a:fld id="{13CDDF33-5728-4730-A3D1-528809E425CB}" type="datetimeFigureOut">
               <a:rPr lang="es-CO" smtClean="0"/>
-              <a:t>3/04/2026</a:t>
+              <a:t>5/04/2026</a:t>
             </a:fld>
             <a:endParaRPr lang="es-CO"/>
           </a:p>
@@ -2173,7 +2210,7 @@
           <a:p>
             <a:fld id="{13CDDF33-5728-4730-A3D1-528809E425CB}" type="datetimeFigureOut">
               <a:rPr lang="es-CO" smtClean="0"/>
-              <a:t>3/04/2026</a:t>
+              <a:t>5/04/2026</a:t>
             </a:fld>
             <a:endParaRPr lang="es-CO"/>
           </a:p>
@@ -2486,7 +2523,7 @@
           <a:p>
             <a:fld id="{13CDDF33-5728-4730-A3D1-528809E425CB}" type="datetimeFigureOut">
               <a:rPr lang="es-CO" smtClean="0"/>
-              <a:t>3/04/2026</a:t>
+              <a:t>5/04/2026</a:t>
             </a:fld>
             <a:endParaRPr lang="es-CO"/>
           </a:p>
@@ -2775,7 +2812,7 @@
           <a:p>
             <a:fld id="{13CDDF33-5728-4730-A3D1-528809E425CB}" type="datetimeFigureOut">
               <a:rPr lang="es-CO" smtClean="0"/>
-              <a:t>3/04/2026</a:t>
+              <a:t>5/04/2026</a:t>
             </a:fld>
             <a:endParaRPr lang="es-CO"/>
           </a:p>
@@ -3018,7 +3055,7 @@
           <a:p>
             <a:fld id="{13CDDF33-5728-4730-A3D1-528809E425CB}" type="datetimeFigureOut">
               <a:rPr lang="es-CO" smtClean="0"/>
-              <a:t>3/04/2026</a:t>
+              <a:t>5/04/2026</a:t>
             </a:fld>
             <a:endParaRPr lang="es-CO"/>
           </a:p>
@@ -3435,42 +3472,99 @@
           <a:chExt cx="0" cy="0"/>
         </a:xfrm>
       </p:grpSpPr>
-      <p:pic>
-        <p:nvPicPr>
-          <p:cNvPr id="13" name="Graphic 12" descr="Pie chart with solid fill">
-            <a:extLst>
-              <a:ext uri="{FF2B5EF4-FFF2-40B4-BE49-F238E27FC236}">
-                <a16:creationId xmlns:a16="http://schemas.microsoft.com/office/drawing/2014/main" id="{A7B3127E-8A0A-1BAD-4F9E-814753B85BDB}"/>
-              </a:ext>
-            </a:extLst>
-          </p:cNvPr>
-          <p:cNvPicPr>
-            <a:picLocks noChangeAspect="1"/>
-          </p:cNvPicPr>
+      <p:grpSp>
+        <p:nvGrpSpPr>
+          <p:cNvPr id="18" name="Group 17">
+            <a:extLst>
+              <a:ext uri="{FF2B5EF4-FFF2-40B4-BE49-F238E27FC236}">
+                <a16:creationId xmlns:a16="http://schemas.microsoft.com/office/drawing/2014/main" id="{A11CBD9B-FDAA-4D8B-8E14-37B7442EC603}"/>
+              </a:ext>
+            </a:extLst>
+          </p:cNvPr>
+          <p:cNvGrpSpPr/>
           <p:nvPr/>
-        </p:nvPicPr>
-        <p:blipFill>
-          <a:blip>
-            <a:extLst>
-              <a:ext uri="{96DAC541-7B7A-43D3-8B79-37D633B846F1}">
-                <asvg:svgBlip xmlns:asvg="http://schemas.microsoft.com/office/drawing/2016/SVG/main" r:embed="rId2"/>
-              </a:ext>
-            </a:extLst>
-          </a:blip>
-          <a:stretch>
-            <a:fillRect/>
-          </a:stretch>
-        </p:blipFill>
-        <p:spPr>
+        </p:nvGrpSpPr>
+        <p:grpSpPr>
           <a:xfrm>
-            <a:off x="4379976" y="1749552"/>
-            <a:ext cx="3124200" cy="3124200"/>
+            <a:off x="3747435" y="2382419"/>
+            <a:ext cx="4750709" cy="2801748"/>
+            <a:chOff x="3747435" y="2382419"/>
+            <a:chExt cx="4750709" cy="2801748"/>
           </a:xfrm>
-          <a:prstGeom prst="rect">
-            <a:avLst/>
-          </a:prstGeom>
-        </p:spPr>
-      </p:pic>
+        </p:grpSpPr>
+        <p:pic>
+          <p:nvPicPr>
+            <p:cNvPr id="15" name="Graphic 14" descr="Building outline">
+              <a:extLst>
+                <a:ext uri="{FF2B5EF4-FFF2-40B4-BE49-F238E27FC236}">
+                  <a16:creationId xmlns:a16="http://schemas.microsoft.com/office/drawing/2014/main" id="{248B42A6-11F3-AA02-6BE1-0C2312602000}"/>
+                </a:ext>
+              </a:extLst>
+            </p:cNvPr>
+            <p:cNvPicPr>
+              <a:picLocks noChangeAspect="1"/>
+            </p:cNvPicPr>
+            <p:nvPr/>
+          </p:nvPicPr>
+          <p:blipFill>
+            <a:blip>
+              <a:extLst>
+                <a:ext uri="{96DAC541-7B7A-43D3-8B79-37D633B846F1}">
+                  <asvg:svgBlip xmlns:asvg="http://schemas.microsoft.com/office/drawing/2016/SVG/main" r:embed="rId2"/>
+                </a:ext>
+              </a:extLst>
+            </a:blip>
+            <a:stretch>
+              <a:fillRect/>
+            </a:stretch>
+          </p:blipFill>
+          <p:spPr>
+            <a:xfrm>
+              <a:off x="3747435" y="2382420"/>
+              <a:ext cx="2801747" cy="2801747"/>
+            </a:xfrm>
+            <a:prstGeom prst="rect">
+              <a:avLst/>
+            </a:prstGeom>
+          </p:spPr>
+        </p:pic>
+        <p:pic>
+          <p:nvPicPr>
+            <p:cNvPr id="17" name="Graphic 16" descr="House with solid fill">
+              <a:extLst>
+                <a:ext uri="{FF2B5EF4-FFF2-40B4-BE49-F238E27FC236}">
+                  <a16:creationId xmlns:a16="http://schemas.microsoft.com/office/drawing/2014/main" id="{5AE1C2AC-7F72-2E18-50EC-484B739A01B4}"/>
+                </a:ext>
+              </a:extLst>
+            </p:cNvPr>
+            <p:cNvPicPr>
+              <a:picLocks noChangeAspect="1"/>
+            </p:cNvPicPr>
+            <p:nvPr/>
+          </p:nvPicPr>
+          <p:blipFill>
+            <a:blip>
+              <a:extLst>
+                <a:ext uri="{96DAC541-7B7A-43D3-8B79-37D633B846F1}">
+                  <asvg:svgBlip xmlns:asvg="http://schemas.microsoft.com/office/drawing/2016/SVG/main" r:embed="rId3"/>
+                </a:ext>
+              </a:extLst>
+            </a:blip>
+            <a:stretch>
+              <a:fillRect/>
+            </a:stretch>
+          </p:blipFill>
+          <p:spPr>
+            <a:xfrm>
+              <a:off x="5696397" y="2382419"/>
+              <a:ext cx="2801747" cy="2801747"/>
+            </a:xfrm>
+            <a:prstGeom prst="rect">
+              <a:avLst/>
+            </a:prstGeom>
+          </p:spPr>
+        </p:pic>
+      </p:grpSp>
     </p:spTree>
     <p:extLst>
       <p:ext uri="{BB962C8B-B14F-4D97-AF65-F5344CB8AC3E}">

</xml_diff>